<commit_message>
chore: update requirements, gitignore, and presentation assets
</commit_message>
<xml_diff>
--- a/Julius_Baer_Wealth_Intelligence_Pitch_Avijit.pptx
+++ b/Julius_Baer_Wealth_Intelligence_Pitch_Avijit.pptx
@@ -19,6 +19,9 @@
     <p:sldId id="266" r:id="rId13"/>
     <p:sldId id="269" r:id="rId14"/>
     <p:sldId id="267" r:id="rId15"/>
+    <p:sldId id="271" r:id="rId16"/>
+    <p:sldId id="270" r:id="rId17"/>
+    <p:sldId id="272" r:id="rId18"/>
   </p:sldIdLst>
   <p:sldSz cx="12192000" cy="6858000"/>
   <p:notesSz cx="6858000" cy="9144000"/>
@@ -6919,6 +6922,1367 @@
         </p:txBody>
       </p:sp>
     </p:spTree>
+  </p:cSld>
+  <p:clrMapOvr>
+    <a:masterClrMapping/>
+  </p:clrMapOvr>
+</p:sld>
+</file>
+
+<file path=ppt/slides/slide15.xml><?xml version="1.0" encoding="utf-8"?>
+<p:sld xmlns:a="http://schemas.openxmlformats.org/drawingml/2006/main" xmlns:r="http://schemas.openxmlformats.org/officeDocument/2006/relationships" xmlns:p="http://schemas.openxmlformats.org/presentationml/2006/main">
+  <p:cSld>
+    <p:spTree>
+      <p:nvGrpSpPr>
+        <p:cNvPr id="1" name=""/>
+        <p:cNvGrpSpPr/>
+        <p:nvPr/>
+      </p:nvGrpSpPr>
+      <p:grpSpPr>
+        <a:xfrm>
+          <a:off x="0" y="0"/>
+          <a:ext cx="0" cy="0"/>
+          <a:chOff x="0" y="0"/>
+          <a:chExt cx="0" cy="0"/>
+        </a:xfrm>
+      </p:grpSpPr>
+      <p:sp>
+        <p:nvSpPr>
+          <p:cNvPr id="2" name="TextBox 1">
+            <a:extLst>
+              <a:ext uri="{FF2B5EF4-FFF2-40B4-BE49-F238E27FC236}">
+                <a16:creationId xmlns:a16="http://schemas.microsoft.com/office/drawing/2014/main" id="{033D21F3-D675-CECD-423F-6342D702414F}"/>
+              </a:ext>
+            </a:extLst>
+          </p:cNvPr>
+          <p:cNvSpPr txBox="1"/>
+          <p:nvPr/>
+        </p:nvSpPr>
+        <p:spPr>
+          <a:xfrm>
+            <a:off x="5205984" y="3145536"/>
+            <a:ext cx="5864352" cy="369332"/>
+          </a:xfrm>
+          <a:prstGeom prst="rect">
+            <a:avLst/>
+          </a:prstGeom>
+          <a:noFill/>
+        </p:spPr>
+        <p:txBody>
+          <a:bodyPr wrap="square" rtlCol="0">
+            <a:spAutoFit/>
+          </a:bodyPr>
+          <a:lstStyle/>
+          <a:p>
+            <a:r>
+              <a:rPr lang="en-US" dirty="0"/>
+              <a:t>Appendix</a:t>
+            </a:r>
+          </a:p>
+        </p:txBody>
+      </p:sp>
+    </p:spTree>
+    <p:extLst>
+      <p:ext uri="{BB962C8B-B14F-4D97-AF65-F5344CB8AC3E}">
+        <p14:creationId xmlns:p14="http://schemas.microsoft.com/office/powerpoint/2010/main" val="797501856"/>
+      </p:ext>
+    </p:extLst>
+  </p:cSld>
+  <p:clrMapOvr>
+    <a:masterClrMapping/>
+  </p:clrMapOvr>
+</p:sld>
+</file>
+
+<file path=ppt/slides/slide16.xml><?xml version="1.0" encoding="utf-8"?>
+<p:sld xmlns:a="http://schemas.openxmlformats.org/drawingml/2006/main" xmlns:r="http://schemas.openxmlformats.org/officeDocument/2006/relationships" xmlns:p="http://schemas.openxmlformats.org/presentationml/2006/main">
+  <p:cSld>
+    <p:spTree>
+      <p:nvGrpSpPr>
+        <p:cNvPr id="1" name="">
+          <a:extLst>
+            <a:ext uri="{FF2B5EF4-FFF2-40B4-BE49-F238E27FC236}">
+              <a16:creationId xmlns:a16="http://schemas.microsoft.com/office/drawing/2014/main" id="{0C01593C-3A2B-69DE-DC8F-04C30EE1AF0C}"/>
+            </a:ext>
+          </a:extLst>
+        </p:cNvPr>
+        <p:cNvGrpSpPr/>
+        <p:nvPr/>
+      </p:nvGrpSpPr>
+      <p:grpSpPr>
+        <a:xfrm>
+          <a:off x="0" y="0"/>
+          <a:ext cx="0" cy="0"/>
+          <a:chOff x="0" y="0"/>
+          <a:chExt cx="0" cy="0"/>
+        </a:xfrm>
+      </p:grpSpPr>
+      <p:sp>
+        <p:nvSpPr>
+          <p:cNvPr id="2" name="TextBox 1">
+            <a:extLst>
+              <a:ext uri="{FF2B5EF4-FFF2-40B4-BE49-F238E27FC236}">
+                <a16:creationId xmlns:a16="http://schemas.microsoft.com/office/drawing/2014/main" id="{91BDD55C-29B5-D180-2101-E7BCDB0D357D}"/>
+              </a:ext>
+            </a:extLst>
+          </p:cNvPr>
+          <p:cNvSpPr txBox="1"/>
+          <p:nvPr/>
+        </p:nvSpPr>
+        <p:spPr>
+          <a:xfrm>
+            <a:off x="731520" y="365760"/>
+            <a:ext cx="10698480" cy="1051560"/>
+          </a:xfrm>
+          <a:prstGeom prst="rect">
+            <a:avLst/>
+          </a:prstGeom>
+          <a:noFill/>
+        </p:spPr>
+        <p:txBody>
+          <a:bodyPr wrap="square" lIns="0" tIns="0" rIns="0" bIns="0">
+            <a:spAutoFit/>
+          </a:bodyPr>
+          <a:lstStyle/>
+          <a:p>
+            <a:pPr>
+              <a:spcAft>
+                <a:spcPts val="200"/>
+              </a:spcAft>
+              <a:defRPr sz="1000" b="1">
+                <a:solidFill>
+                  <a:srgbClr val="C5A059"/>
+                </a:solidFill>
+              </a:defRPr>
+            </a:pPr>
+            <a:r>
+              <a:rPr dirty="0"/>
+              <a:t>CURRENT SYSTEM ARCHITECTURE</a:t>
+            </a:r>
+          </a:p>
+          <a:p>
+            <a:pPr>
+              <a:defRPr sz="2100" b="1">
+                <a:solidFill>
+                  <a:srgbClr val="0C1A30"/>
+                </a:solidFill>
+              </a:defRPr>
+            </a:pPr>
+            <a:r>
+              <a:rPr dirty="0"/>
+              <a:t>Current Setup: Three-Tier Agent Swarm &amp; Deterministic Orchestration</a:t>
+            </a:r>
+          </a:p>
+        </p:txBody>
+      </p:sp>
+      <p:sp>
+        <p:nvSpPr>
+          <p:cNvPr id="14" name="TextBox 13">
+            <a:extLst>
+              <a:ext uri="{FF2B5EF4-FFF2-40B4-BE49-F238E27FC236}">
+                <a16:creationId xmlns:a16="http://schemas.microsoft.com/office/drawing/2014/main" id="{CD7FEF41-0B8C-FAFE-9435-6C578348B871}"/>
+              </a:ext>
+            </a:extLst>
+          </p:cNvPr>
+          <p:cNvSpPr txBox="1"/>
+          <p:nvPr/>
+        </p:nvSpPr>
+        <p:spPr>
+          <a:xfrm>
+            <a:off x="329184" y="999744"/>
+            <a:ext cx="11655552" cy="5909310"/>
+          </a:xfrm>
+          <a:prstGeom prst="rect">
+            <a:avLst/>
+          </a:prstGeom>
+          <a:noFill/>
+        </p:spPr>
+        <p:txBody>
+          <a:bodyPr wrap="square" rtlCol="0">
+            <a:spAutoFit/>
+          </a:bodyPr>
+          <a:lstStyle/>
+          <a:p>
+            <a:r>
+              <a:rPr lang="en-SG" sz="900" dirty="0"/>
+              <a:t>Key Components &amp; Structural Breakdown</a:t>
+            </a:r>
+          </a:p>
+          <a:p>
+            <a:r>
+              <a:rPr lang="en-SG" sz="900" dirty="0"/>
+              <a:t>1. Specialist Agent Swarm (</a:t>
+            </a:r>
+            <a:r>
+              <a:rPr lang="en-SG" sz="900" dirty="0" err="1"/>
+              <a:t>src</a:t>
+            </a:r>
+            <a:r>
+              <a:rPr lang="en-SG" sz="900" dirty="0"/>
+              <a:t>/</a:t>
+            </a:r>
+            <a:r>
+              <a:rPr lang="en-SG" sz="900" dirty="0" err="1"/>
+              <a:t>specialist_agents.py</a:t>
+            </a:r>
+            <a:r>
+              <a:rPr lang="en-SG" sz="900" dirty="0"/>
+              <a:t>)</a:t>
+            </a:r>
+          </a:p>
+          <a:p>
+            <a:r>
+              <a:rPr lang="en-SG" sz="900" dirty="0"/>
+              <a:t>Each specialist agent focuses on a single domain using deterministic calculations from </a:t>
+            </a:r>
+            <a:r>
+              <a:rPr lang="en-SG" sz="900" dirty="0" err="1"/>
+              <a:t>DeterministicAnalytics</a:t>
+            </a:r>
+            <a:r>
+              <a:rPr lang="en-SG" sz="900" dirty="0"/>
+              <a:t>:</a:t>
+            </a:r>
+          </a:p>
+          <a:p>
+            <a:pPr lvl="0"/>
+            <a:r>
+              <a:rPr lang="en-SG" sz="900" b="1" dirty="0" err="1"/>
+              <a:t>RebalancingAgent</a:t>
+            </a:r>
+            <a:r>
+              <a:rPr lang="en-SG" sz="900" dirty="0"/>
+              <a:t>: Evaluates asset allocation drift, single-instrument concentration breaches, and cash mandate boundaries.</a:t>
+            </a:r>
+          </a:p>
+          <a:p>
+            <a:pPr lvl="0"/>
+            <a:r>
+              <a:rPr lang="en-SG" sz="900" b="1" dirty="0" err="1"/>
+              <a:t>TaxOptimizationAgent</a:t>
+            </a:r>
+            <a:r>
+              <a:rPr lang="en-SG" sz="900" dirty="0"/>
+              <a:t>: Scans unrealized loss lots for tax-loss harvesting based on jurisdictional rules (e.g., US 30-day wash-sale, UK CGT allowances).</a:t>
+            </a:r>
+          </a:p>
+          <a:p>
+            <a:pPr lvl="0"/>
+            <a:r>
+              <a:rPr lang="en-SG" sz="900" b="1" dirty="0" err="1"/>
+              <a:t>LifeEventPlanningAgent</a:t>
+            </a:r>
+            <a:r>
+              <a:rPr lang="en-SG" sz="900" dirty="0"/>
+              <a:t>: Flags upcoming milestone outflows (e.g., real estate, tuition, estate transfers) and computes ring-fencing timelines.</a:t>
+            </a:r>
+          </a:p>
+          <a:p>
+            <a:pPr lvl="0"/>
+            <a:r>
+              <a:rPr lang="en-SG" sz="900" b="1" dirty="0" err="1"/>
+              <a:t>LiquidityCreditRiskAgent</a:t>
+            </a:r>
+            <a:r>
+              <a:rPr lang="en-SG" sz="900" dirty="0"/>
+              <a:t>: Monitors Lombard lending facilities, LTV covenant margin buffers, and capital call coverage.</a:t>
+            </a:r>
+          </a:p>
+          <a:p>
+            <a:pPr lvl="0"/>
+            <a:r>
+              <a:rPr lang="en-SG" sz="900" b="1" dirty="0" err="1"/>
+              <a:t>MarketImpactAgent</a:t>
+            </a:r>
+            <a:r>
+              <a:rPr lang="en-SG" sz="900" dirty="0"/>
+              <a:t>: </a:t>
+            </a:r>
+            <a:r>
+              <a:rPr lang="en-SG" sz="900" dirty="0" err="1"/>
+              <a:t>Analyzes</a:t>
+            </a:r>
+            <a:r>
+              <a:rPr lang="en-SG" sz="900" dirty="0"/>
+              <a:t> 2026 macro events from </a:t>
+            </a:r>
+          </a:p>
+          <a:p>
+            <a:pPr lvl="0"/>
+            <a:r>
+              <a:rPr lang="en-SG" sz="900" dirty="0" err="1"/>
+              <a:t>event_log.csv</a:t>
+            </a:r>
+            <a:r>
+              <a:rPr lang="en-SG" sz="900" dirty="0"/>
+              <a:t> and calculates portfolio shock transmission.</a:t>
+            </a:r>
+          </a:p>
+          <a:p>
+            <a:pPr lvl="0"/>
+            <a:r>
+              <a:rPr lang="en-SG" sz="900" b="1" dirty="0" err="1"/>
+              <a:t>RMNotesAgent</a:t>
+            </a:r>
+            <a:r>
+              <a:rPr lang="en-SG" sz="900" dirty="0"/>
+              <a:t>: Parses qualitative meeting notes for standing constraints, emotional biases (loss aversion), and legacy holding exclusions.</a:t>
+            </a:r>
+          </a:p>
+          <a:p>
+            <a:br>
+              <a:rPr lang="en-SG" sz="900" dirty="0"/>
+            </a:br>
+            <a:endParaRPr lang="en-SG" sz="900" dirty="0"/>
+          </a:p>
+          <a:p>
+            <a:r>
+              <a:rPr lang="en-SG" sz="900" dirty="0"/>
+              <a:t>2. Master Orchestrator (</a:t>
+            </a:r>
+            <a:r>
+              <a:rPr lang="en-SG" sz="900" dirty="0" err="1"/>
+              <a:t>src</a:t>
+            </a:r>
+            <a:r>
+              <a:rPr lang="en-SG" sz="900" dirty="0"/>
+              <a:t>/</a:t>
+            </a:r>
+            <a:r>
+              <a:rPr lang="en-SG" sz="900" dirty="0" err="1"/>
+              <a:t>orchestrator.py</a:t>
+            </a:r>
+            <a:r>
+              <a:rPr lang="en-SG" sz="900" dirty="0"/>
+              <a:t>)</a:t>
+            </a:r>
+          </a:p>
+          <a:p>
+            <a:r>
+              <a:rPr lang="en-SG" sz="900" dirty="0"/>
+              <a:t>The </a:t>
+            </a:r>
+            <a:r>
+              <a:rPr lang="en-SG" sz="900" b="1" dirty="0" err="1"/>
+              <a:t>ClientOrchestrator</a:t>
+            </a:r>
+            <a:r>
+              <a:rPr lang="en-SG" sz="900" dirty="0"/>
+              <a:t> ingests raw specialist proposals and coordinates the multi-agent synthesis:</a:t>
+            </a:r>
+          </a:p>
+          <a:p>
+            <a:r>
+              <a:rPr lang="en-SG" sz="900" b="1" dirty="0"/>
+              <a:t>A. De-Duplication Engine (_</a:t>
+            </a:r>
+            <a:r>
+              <a:rPr lang="en-SG" sz="900" b="1" dirty="0" err="1"/>
+              <a:t>deduplicate_and_synthesize_recs</a:t>
+            </a:r>
+            <a:r>
+              <a:rPr lang="en-SG" sz="900" b="1" dirty="0"/>
+              <a:t>)</a:t>
+            </a:r>
+          </a:p>
+          <a:p>
+            <a:pPr lvl="0"/>
+            <a:r>
+              <a:rPr lang="en-SG" sz="900" b="1" dirty="0"/>
+              <a:t>Role:</a:t>
+            </a:r>
+            <a:r>
+              <a:rPr lang="en-SG" sz="900" dirty="0"/>
+              <a:t> Eliminates noise and redundant alerts across agents.</a:t>
+            </a:r>
+          </a:p>
+          <a:p>
+            <a:pPr lvl="0"/>
+            <a:r>
+              <a:rPr lang="en-SG" sz="900" b="1" dirty="0"/>
+              <a:t>How it works:</a:t>
+            </a:r>
+            <a:r>
+              <a:rPr lang="en-SG" sz="900" dirty="0"/>
+              <a:t> When both the </a:t>
+            </a:r>
+            <a:r>
+              <a:rPr lang="en-SG" sz="900" dirty="0" err="1"/>
+              <a:t>RebalancingAgent</a:t>
+            </a:r>
+            <a:r>
+              <a:rPr lang="en-SG" sz="900" dirty="0"/>
+              <a:t> and the </a:t>
+            </a:r>
+            <a:r>
+              <a:rPr lang="en-SG" sz="900" dirty="0" err="1"/>
+              <a:t>MarketImpactAgent</a:t>
+            </a:r>
+            <a:r>
+              <a:rPr lang="en-SG" sz="900" dirty="0"/>
+              <a:t> trigger actions on the same asset class or holding (e.g., energy/commodities trim), the Orchestrator absorbs the market shock transmission into the rebalancing rationale and suppresses redundant standalone market alerts.</a:t>
+            </a:r>
+          </a:p>
+          <a:p>
+            <a:r>
+              <a:rPr lang="en-SG" sz="900" b="1" dirty="0"/>
+              <a:t>B. Conflict Detection &amp; Resolution Engine (_</a:t>
+            </a:r>
+            <a:r>
+              <a:rPr lang="en-SG" sz="900" b="1" dirty="0" err="1"/>
+              <a:t>detect_conflicts</a:t>
+            </a:r>
+            <a:r>
+              <a:rPr lang="en-SG" sz="900" b="1" dirty="0"/>
+              <a:t>)</a:t>
+            </a:r>
+          </a:p>
+          <a:p>
+            <a:pPr lvl="0"/>
+            <a:r>
+              <a:rPr lang="en-SG" sz="900" b="1" dirty="0"/>
+              <a:t>Role:</a:t>
+            </a:r>
+            <a:r>
+              <a:rPr lang="en-SG" sz="900" dirty="0"/>
+              <a:t> Surfaces contradictions between quantitative mandates and client constraints.</a:t>
+            </a:r>
+          </a:p>
+          <a:p>
+            <a:pPr lvl="0"/>
+            <a:r>
+              <a:rPr lang="en-SG" sz="900" b="1" dirty="0"/>
+              <a:t>Key Capabilities:</a:t>
+            </a:r>
+            <a:endParaRPr lang="en-SG" sz="900" dirty="0"/>
+          </a:p>
+          <a:p>
+            <a:pPr lvl="1"/>
+            <a:r>
+              <a:rPr lang="en-SG" sz="900" b="1" dirty="0"/>
+              <a:t>Mandate Rebalance vs. Standing Constraint:</a:t>
+            </a:r>
+            <a:r>
+              <a:rPr lang="en-SG" sz="900" dirty="0"/>
+              <a:t> Detects when a rebalancing trim targets a restricted legacy holding (e.g., CL-0001 Bara Nusantara Energy).</a:t>
+            </a:r>
+          </a:p>
+          <a:p>
+            <a:pPr lvl="1"/>
+            <a:r>
+              <a:rPr lang="en-SG" sz="900" b="1" dirty="0"/>
+              <a:t>Bidirectional Linking:</a:t>
+            </a:r>
+            <a:r>
+              <a:rPr lang="en-SG" sz="900" dirty="0"/>
+              <a:t> Cross-references </a:t>
+            </a:r>
+            <a:r>
+              <a:rPr lang="en-SG" sz="900" dirty="0" err="1"/>
+              <a:t>rec_a</a:t>
+            </a:r>
+            <a:r>
+              <a:rPr lang="en-SG" sz="900" dirty="0"/>
+              <a:t> and </a:t>
+            </a:r>
+            <a:r>
+              <a:rPr lang="en-SG" sz="900" dirty="0" err="1"/>
+              <a:t>rec_b</a:t>
+            </a:r>
+            <a:r>
+              <a:rPr lang="en-SG" sz="900" dirty="0"/>
+              <a:t> via </a:t>
+            </a:r>
+            <a:r>
+              <a:rPr lang="en-SG" sz="900" dirty="0" err="1"/>
+              <a:t>conflicts_with</a:t>
+            </a:r>
+            <a:r>
+              <a:rPr lang="en-SG" sz="900" dirty="0"/>
+              <a:t>.</a:t>
+            </a:r>
+          </a:p>
+          <a:p>
+            <a:pPr lvl="1"/>
+            <a:r>
+              <a:rPr lang="en-SG" sz="900" b="1" dirty="0"/>
+              <a:t>Actionable Governance Resolution:</a:t>
+            </a:r>
+            <a:r>
+              <a:rPr lang="en-SG" sz="900" dirty="0"/>
+              <a:t> Formulates documented trade-offs and recommends structured resolutions (e.g., </a:t>
+            </a:r>
+            <a:r>
+              <a:rPr lang="en-SG" sz="900" i="1" dirty="0"/>
+              <a:t>“Maintain strategic holding under suitability waiver; rebalance surrounding liquid sleeves”</a:t>
+            </a:r>
+            <a:r>
+              <a:rPr lang="en-SG" sz="900" dirty="0"/>
+              <a:t>).</a:t>
+            </a:r>
+          </a:p>
+          <a:p>
+            <a:r>
+              <a:rPr lang="en-SG" sz="900" b="1" dirty="0"/>
+              <a:t>C. Synergistic Comingling Engine (_</a:t>
+            </a:r>
+            <a:r>
+              <a:rPr lang="en-SG" sz="900" b="1" dirty="0" err="1"/>
+              <a:t>detect_comingling_opportunities</a:t>
+            </a:r>
+            <a:r>
+              <a:rPr lang="en-SG" sz="900" b="1" dirty="0"/>
+              <a:t>)</a:t>
+            </a:r>
+          </a:p>
+          <a:p>
+            <a:pPr lvl="0"/>
+            <a:r>
+              <a:rPr lang="en-SG" sz="900" b="1" dirty="0"/>
+              <a:t>Role:</a:t>
+            </a:r>
+            <a:r>
+              <a:rPr lang="en-SG" sz="900" dirty="0"/>
+              <a:t> Packages discrete, multi-agent actions into a unified client strategy.</a:t>
+            </a:r>
+          </a:p>
+          <a:p>
+            <a:pPr lvl="0"/>
+            <a:r>
+              <a:rPr lang="en-SG" sz="900" b="1" dirty="0"/>
+              <a:t>Conflict Integration:</a:t>
+            </a:r>
+            <a:endParaRPr lang="en-SG" sz="900" dirty="0"/>
+          </a:p>
+          <a:p>
+            <a:pPr lvl="1"/>
+            <a:r>
+              <a:rPr lang="en-SG" sz="900" dirty="0"/>
+              <a:t>Separates </a:t>
+            </a:r>
+            <a:r>
+              <a:rPr lang="en-SG" sz="900" b="1" dirty="0"/>
+              <a:t>liquid rebalancing trims</a:t>
+            </a:r>
+            <a:r>
+              <a:rPr lang="en-SG" sz="900" dirty="0"/>
+              <a:t> (Global Equity, Credit) from </a:t>
+            </a:r>
+            <a:r>
+              <a:rPr lang="en-SG" sz="900" b="1" dirty="0"/>
+              <a:t>conflict-reconciled assets</a:t>
+            </a:r>
+            <a:r>
+              <a:rPr lang="en-SG" sz="900" dirty="0"/>
+              <a:t> (Bara Nusantara Energy).</a:t>
+            </a:r>
+          </a:p>
+          <a:p>
+            <a:pPr lvl="1"/>
+            <a:r>
+              <a:rPr lang="en-SG" sz="900" dirty="0"/>
+              <a:t>Clubs liquid trims, tax-loss harvesting, milestone funding, and cash fortification into a single holistic proposal.</a:t>
+            </a:r>
+          </a:p>
+          <a:p>
+            <a:pPr lvl="1"/>
+            <a:r>
+              <a:rPr lang="en-SG" sz="900" dirty="0"/>
+              <a:t>Generates unified private banking talking points, synchronized execution timelines (e.g., 30-day window), and a dedicated ⚖️ Conflict Reconciled badge in the UI.</a:t>
+            </a:r>
+          </a:p>
+          <a:p>
+            <a:r>
+              <a:rPr lang="en-SG" sz="900" b="1" dirty="0"/>
+              <a:t>D. Cross-Specialist Optimization Engine (_</a:t>
+            </a:r>
+            <a:r>
+              <a:rPr lang="en-SG" sz="900" b="1" dirty="0" err="1"/>
+              <a:t>detect_cross_specialist_optimizations</a:t>
+            </a:r>
+            <a:r>
+              <a:rPr lang="en-SG" sz="900" b="1" dirty="0"/>
+              <a:t>)</a:t>
+            </a:r>
+          </a:p>
+          <a:p>
+            <a:pPr lvl="0"/>
+            <a:r>
+              <a:rPr lang="en-SG" sz="900" b="1" dirty="0"/>
+              <a:t>Role:</a:t>
+            </a:r>
+            <a:r>
+              <a:rPr lang="en-SG" sz="900" dirty="0"/>
+              <a:t> Uncovers high-alpha, cross-sleeve optimizations that no single specialist could see in isolation:</a:t>
+            </a:r>
+          </a:p>
+          <a:p>
+            <a:pPr lvl="1"/>
+            <a:r>
+              <a:rPr lang="en-SG" sz="900" b="1" dirty="0"/>
+              <a:t>Cross-Sleeve Tax-Alpha Matrix:</a:t>
+            </a:r>
+            <a:r>
+              <a:rPr lang="en-SG" sz="900" dirty="0"/>
+              <a:t> Synchronizes capital gains rebalancing with loss harvesting across portfolios to eliminate tax drag.</a:t>
+            </a:r>
+          </a:p>
+          <a:p>
+            <a:pPr lvl="1"/>
+            <a:r>
+              <a:rPr lang="en-SG" sz="900" b="1" dirty="0"/>
+              <a:t>Staged Liquidity Immunization:</a:t>
+            </a:r>
+            <a:r>
+              <a:rPr lang="en-SG" sz="900" dirty="0"/>
+              <a:t> Creates dynamic short-duration Treasury sweeps to eliminate ~45–60 bps of cash drag while guaranteeing milestone coverage.</a:t>
+            </a:r>
+          </a:p>
+          <a:p>
+            <a:pPr lvl="1"/>
+            <a:r>
+              <a:rPr lang="en-SG" sz="900" b="1" dirty="0"/>
+              <a:t>Collateral Downside Shield:</a:t>
+            </a:r>
+            <a:r>
+              <a:rPr lang="en-SG" sz="900" dirty="0"/>
+              <a:t> Applies duration/volatility collars to credit collateral assets to preserve Lombard LTV headroom.</a:t>
+            </a:r>
+          </a:p>
+          <a:p>
+            <a:pPr lvl="1"/>
+            <a:r>
+              <a:rPr lang="en-SG" sz="900" b="1" dirty="0"/>
+              <a:t>Fixed Income Duration Barbell &amp; Income Shield (e.g., CL-0012):</a:t>
+            </a:r>
+            <a:r>
+              <a:rPr lang="en-SG" sz="900" dirty="0"/>
+              <a:t> Constructs a 2-Year US Treasury ladder (~5.1% yield) to fund living expenses without selling underwater 2045 long-duration bonds at a loss.</a:t>
+            </a:r>
+          </a:p>
+          <a:p>
+            <a:br>
+              <a:rPr lang="en-SG" sz="900" dirty="0"/>
+            </a:br>
+            <a:endParaRPr lang="en-SG" sz="900" dirty="0"/>
+          </a:p>
+          <a:p>
+            <a:r>
+              <a:rPr lang="en-SG" sz="900" dirty="0"/>
+              <a:t>3. Dual-Path Execution (LLM Intelligence + Deterministic Fallback)</a:t>
+            </a:r>
+          </a:p>
+          <a:p>
+            <a:pPr lvl="0"/>
+            <a:r>
+              <a:rPr lang="en-SG" sz="900" b="1" dirty="0"/>
+              <a:t>Live LLM Orchestration:</a:t>
+            </a:r>
+            <a:r>
+              <a:rPr lang="en-SG" sz="900" dirty="0"/>
+              <a:t> When an LLM API key is present, </a:t>
+            </a:r>
+          </a:p>
+          <a:p>
+            <a:pPr lvl="0"/>
+            <a:r>
+              <a:rPr lang="en-SG" sz="900" dirty="0"/>
+              <a:t>_</a:t>
+            </a:r>
+            <a:r>
+              <a:rPr lang="en-SG" sz="900" dirty="0" err="1"/>
+              <a:t>run_llm_orchestrator</a:t>
+            </a:r>
+            <a:r>
+              <a:rPr lang="en-SG" sz="900" dirty="0"/>
+              <a:t> reasons across all specialist inputs using Julius Baer CIO persona prompts.</a:t>
+            </a:r>
+          </a:p>
+          <a:p>
+            <a:pPr lvl="0"/>
+            <a:r>
+              <a:rPr lang="en-SG" sz="900" b="1" dirty="0"/>
+              <a:t>Deterministic Rule Fallback:</a:t>
+            </a:r>
+            <a:r>
+              <a:rPr lang="en-SG" sz="900" dirty="0"/>
+              <a:t> When LLM is offline or in mock mode, the deterministic rule engine executes identical de-duplication, conflict detection, comingling synthesis, and cross-specialist optimization pipelines with 100% reproducibility.</a:t>
+            </a:r>
+          </a:p>
+        </p:txBody>
+      </p:sp>
+    </p:spTree>
+    <p:extLst>
+      <p:ext uri="{BB962C8B-B14F-4D97-AF65-F5344CB8AC3E}">
+        <p14:creationId xmlns:p14="http://schemas.microsoft.com/office/powerpoint/2010/main" val="255537887"/>
+      </p:ext>
+    </p:extLst>
+  </p:cSld>
+  <p:clrMapOvr>
+    <a:masterClrMapping/>
+  </p:clrMapOvr>
+</p:sld>
+</file>
+
+<file path=ppt/slides/slide17.xml><?xml version="1.0" encoding="utf-8"?>
+<p:sld xmlns:a="http://schemas.openxmlformats.org/drawingml/2006/main" xmlns:r="http://schemas.openxmlformats.org/officeDocument/2006/relationships" xmlns:p="http://schemas.openxmlformats.org/presentationml/2006/main">
+  <p:cSld>
+    <p:spTree>
+      <p:nvGrpSpPr>
+        <p:cNvPr id="1" name=""/>
+        <p:cNvGrpSpPr/>
+        <p:nvPr/>
+      </p:nvGrpSpPr>
+      <p:grpSpPr>
+        <a:xfrm>
+          <a:off x="0" y="0"/>
+          <a:ext cx="0" cy="0"/>
+          <a:chOff x="0" y="0"/>
+          <a:chExt cx="0" cy="0"/>
+        </a:xfrm>
+      </p:grpSpPr>
+      <p:sp>
+        <p:nvSpPr>
+          <p:cNvPr id="2" name="TextBox 1">
+            <a:extLst>
+              <a:ext uri="{FF2B5EF4-FFF2-40B4-BE49-F238E27FC236}">
+                <a16:creationId xmlns:a16="http://schemas.microsoft.com/office/drawing/2014/main" id="{77A95AD5-679E-AAC3-D25C-A083D2606965}"/>
+              </a:ext>
+            </a:extLst>
+          </p:cNvPr>
+          <p:cNvSpPr txBox="1"/>
+          <p:nvPr/>
+        </p:nvSpPr>
+        <p:spPr>
+          <a:xfrm>
+            <a:off x="731520" y="365760"/>
+            <a:ext cx="10698480" cy="502702"/>
+          </a:xfrm>
+          <a:prstGeom prst="rect">
+            <a:avLst/>
+          </a:prstGeom>
+          <a:noFill/>
+        </p:spPr>
+        <p:txBody>
+          <a:bodyPr wrap="square" lIns="0" tIns="0" rIns="0" bIns="0">
+            <a:spAutoFit/>
+          </a:bodyPr>
+          <a:lstStyle/>
+          <a:p>
+            <a:pPr>
+              <a:spcAft>
+                <a:spcPts val="200"/>
+              </a:spcAft>
+              <a:defRPr sz="1000" b="1">
+                <a:solidFill>
+                  <a:srgbClr val="C5A059"/>
+                </a:solidFill>
+              </a:defRPr>
+            </a:pPr>
+            <a:r>
+              <a:rPr lang="en-US" dirty="0"/>
+              <a:t>Data Issues</a:t>
+            </a:r>
+            <a:endParaRPr dirty="0"/>
+          </a:p>
+          <a:p>
+            <a:pPr>
+              <a:defRPr sz="2100" b="1">
+                <a:solidFill>
+                  <a:srgbClr val="0C1A30"/>
+                </a:solidFill>
+              </a:defRPr>
+            </a:pPr>
+            <a:r>
+              <a:rPr lang="en-US" dirty="0"/>
+              <a:t>Data Issues identified and handled</a:t>
+            </a:r>
+            <a:endParaRPr dirty="0"/>
+          </a:p>
+        </p:txBody>
+      </p:sp>
+      <p:sp>
+        <p:nvSpPr>
+          <p:cNvPr id="7" name="TextBox 6">
+            <a:extLst>
+              <a:ext uri="{FF2B5EF4-FFF2-40B4-BE49-F238E27FC236}">
+                <a16:creationId xmlns:a16="http://schemas.microsoft.com/office/drawing/2014/main" id="{35BD169E-20EF-A998-C09E-D13AF13EBF70}"/>
+              </a:ext>
+            </a:extLst>
+          </p:cNvPr>
+          <p:cNvSpPr txBox="1"/>
+          <p:nvPr/>
+        </p:nvSpPr>
+        <p:spPr>
+          <a:xfrm>
+            <a:off x="950976" y="1219200"/>
+            <a:ext cx="8302752" cy="4523232"/>
+          </a:xfrm>
+          <a:prstGeom prst="rect">
+            <a:avLst/>
+          </a:prstGeom>
+          <a:noFill/>
+        </p:spPr>
+        <p:txBody>
+          <a:bodyPr wrap="square" rtlCol="0">
+            <a:spAutoFit/>
+          </a:bodyPr>
+          <a:lstStyle/>
+          <a:p>
+            <a:endParaRPr lang="en-US" dirty="0"/>
+          </a:p>
+        </p:txBody>
+      </p:sp>
+      <p:sp>
+        <p:nvSpPr>
+          <p:cNvPr id="9" name="TextBox 8">
+            <a:extLst>
+              <a:ext uri="{FF2B5EF4-FFF2-40B4-BE49-F238E27FC236}">
+                <a16:creationId xmlns:a16="http://schemas.microsoft.com/office/drawing/2014/main" id="{130C9ACA-E10F-6402-495E-BF9545BA8BD2}"/>
+              </a:ext>
+            </a:extLst>
+          </p:cNvPr>
+          <p:cNvSpPr txBox="1"/>
+          <p:nvPr/>
+        </p:nvSpPr>
+        <p:spPr>
+          <a:xfrm>
+            <a:off x="731520" y="1024128"/>
+            <a:ext cx="10802112" cy="5386090"/>
+          </a:xfrm>
+          <a:prstGeom prst="rect">
+            <a:avLst/>
+          </a:prstGeom>
+          <a:noFill/>
+        </p:spPr>
+        <p:txBody>
+          <a:bodyPr wrap="square" rtlCol="0">
+            <a:spAutoFit/>
+          </a:bodyPr>
+          <a:lstStyle/>
+          <a:p>
+            <a:pPr marL="342900" indent="-342900">
+              <a:buAutoNum type="arabicPeriod"/>
+            </a:pPr>
+            <a:r>
+              <a:rPr lang="en-US" sz="800" b="1" dirty="0"/>
+              <a:t>Corporate &amp; Family Office Entities (Missing Demographics)</a:t>
+            </a:r>
+          </a:p>
+          <a:p>
+            <a:r>
+              <a:rPr lang="en-US" sz="800" dirty="0"/>
+              <a:t>The Imperfection: Institutional vehicles and family offices (e.g., Fong Enterprises Family Office / CL-0004) have age = </a:t>
+            </a:r>
+            <a:r>
+              <a:rPr lang="en-US" sz="800" dirty="0" err="1"/>
+              <a:t>NaN</a:t>
+            </a:r>
+            <a:r>
+              <a:rPr lang="en-US" sz="800" dirty="0"/>
+              <a:t> and gender = </a:t>
+            </a:r>
+            <a:r>
+              <a:rPr lang="en-US" sz="800" dirty="0" err="1"/>
+              <a:t>NaN</a:t>
+            </a:r>
+            <a:r>
+              <a:rPr lang="en-US" sz="800" dirty="0"/>
+              <a:t>.</a:t>
+            </a:r>
+          </a:p>
+          <a:p>
+            <a:r>
+              <a:rPr lang="en-US" sz="800" dirty="0"/>
+              <a:t>The Risk: Naive systems crash with </a:t>
+            </a:r>
+            <a:r>
+              <a:rPr lang="en-US" sz="800" dirty="0" err="1"/>
+              <a:t>ValueError</a:t>
+            </a:r>
+            <a:r>
+              <a:rPr lang="en-US" sz="800" dirty="0"/>
+              <a:t>: cannot convert float </a:t>
+            </a:r>
+            <a:r>
+              <a:rPr lang="en-US" sz="800" dirty="0" err="1"/>
+              <a:t>NaN</a:t>
+            </a:r>
+            <a:r>
+              <a:rPr lang="en-US" sz="800" dirty="0"/>
+              <a:t> to integer or display awkward labels like "</a:t>
+            </a:r>
+            <a:r>
+              <a:rPr lang="en-US" sz="800" dirty="0" err="1"/>
+              <a:t>NaN</a:t>
+            </a:r>
+            <a:r>
+              <a:rPr lang="en-US" sz="800" dirty="0"/>
+              <a:t> years old".</a:t>
+            </a:r>
+          </a:p>
+          <a:p>
+            <a:r>
+              <a:rPr lang="en-US" sz="800" dirty="0"/>
+              <a:t>Thoughtful Handling:</a:t>
+            </a:r>
+          </a:p>
+          <a:p>
+            <a:r>
+              <a:rPr lang="en-US" sz="800" dirty="0"/>
+              <a:t>Polymorphic Client Profiles: The data and UI layers check for missing demographic attributes and render Corporate Entity / Family Office or Institutional Mandate instead of attempting numeric conversions.</a:t>
+            </a:r>
+          </a:p>
+          <a:p>
+            <a:r>
+              <a:rPr lang="en-US" sz="800" dirty="0"/>
+              <a:t>Entity-Aware KYC: KYC review cycles are evaluated against corporate regulatory timelines rather than human life stages.</a:t>
+            </a:r>
+          </a:p>
+          <a:p>
+            <a:endParaRPr lang="en-US" sz="800" dirty="0"/>
+          </a:p>
+          <a:p>
+            <a:r>
+              <a:rPr lang="en-US" sz="800" b="1" dirty="0"/>
+              <a:t>2. Structured Products &amp; "Worst-Of" Basket Look-Throughs</a:t>
+            </a:r>
+          </a:p>
+          <a:p>
+            <a:r>
+              <a:rPr lang="en-US" sz="800" dirty="0"/>
+              <a:t>The Imperfection: Complex derivatives (FCNs, </a:t>
+            </a:r>
+            <a:r>
+              <a:rPr lang="en-US" sz="800" dirty="0" err="1"/>
+              <a:t>Autocallables</a:t>
+            </a:r>
+            <a:r>
+              <a:rPr lang="en-US" sz="800" dirty="0"/>
+              <a:t>, Accumulators) have sector = </a:t>
+            </a:r>
+            <a:r>
+              <a:rPr lang="en-US" sz="800" dirty="0" err="1"/>
+              <a:t>NaN</a:t>
+            </a:r>
+            <a:r>
+              <a:rPr lang="en-US" sz="800" dirty="0"/>
+              <a:t> or composite text strings in </a:t>
+            </a:r>
+            <a:r>
+              <a:rPr lang="en-US" sz="800" dirty="0" err="1"/>
+              <a:t>underlying_reference</a:t>
+            </a:r>
+            <a:r>
+              <a:rPr lang="en-US" sz="800" dirty="0"/>
+              <a:t> (e.g., "Worst-of basket: Global Energy Majors ADR / Gulf Marine Services / Helios Cloud Systems").</a:t>
+            </a:r>
+          </a:p>
+          <a:p>
+            <a:r>
+              <a:rPr lang="en-US" sz="800" dirty="0"/>
+              <a:t>The Risk: Core banking treats the structured note as a generic "Structured Product" wrapper, completely blinding the RM and risk system to the underlying concentration in Helios or Energy.</a:t>
+            </a:r>
+          </a:p>
+          <a:p>
+            <a:r>
+              <a:rPr lang="en-US" sz="800" dirty="0"/>
+              <a:t>Thoughtful Handling:</a:t>
+            </a:r>
+          </a:p>
+          <a:p>
+            <a:r>
+              <a:rPr lang="en-US" sz="800" dirty="0"/>
+              <a:t>Deterministic Look-Through Decomposition: </a:t>
+            </a:r>
+          </a:p>
+          <a:p>
+            <a:r>
+              <a:rPr lang="en-US" sz="800" dirty="0" err="1"/>
+              <a:t>resolve_look_through</a:t>
+            </a:r>
+            <a:r>
+              <a:rPr lang="en-US" sz="800" dirty="0"/>
+              <a:t>() parses underlying tickers and divides economic exposure across the basket components.</a:t>
+            </a:r>
+          </a:p>
+          <a:p>
+            <a:r>
+              <a:rPr lang="en-US" sz="800" dirty="0"/>
+              <a:t>Multi-Asset Tagging: Replaces missing GICS sectors with synthetic sector tags derived from the basket's underlying constituents.</a:t>
+            </a:r>
+          </a:p>
+          <a:p>
+            <a:endParaRPr lang="en-US" sz="800" dirty="0"/>
+          </a:p>
+          <a:p>
+            <a:r>
+              <a:rPr lang="en-US" sz="800" b="1" dirty="0"/>
+              <a:t>3. Ledger Transactions Without Instrument IDs (Fees &amp; Cash Moves)</a:t>
+            </a:r>
+          </a:p>
+          <a:p>
+            <a:r>
+              <a:rPr lang="en-US" sz="800" dirty="0"/>
+              <a:t>The Imperfection: 65 transaction records (Management Fee, Interest Charge, Facility Drawdown, Withdrawal, Transfer In) naturally have </a:t>
+            </a:r>
+            <a:r>
+              <a:rPr lang="en-US" sz="800" dirty="0" err="1"/>
+              <a:t>instrument_id</a:t>
+            </a:r>
+            <a:r>
+              <a:rPr lang="en-US" sz="800" dirty="0"/>
+              <a:t> = </a:t>
+            </a:r>
+            <a:r>
+              <a:rPr lang="en-US" sz="800" dirty="0" err="1"/>
+              <a:t>NaN</a:t>
+            </a:r>
+            <a:r>
+              <a:rPr lang="en-US" sz="800" dirty="0"/>
+              <a:t> and </a:t>
+            </a:r>
+            <a:r>
+              <a:rPr lang="en-US" sz="800" dirty="0" err="1"/>
+              <a:t>instrument_name</a:t>
+            </a:r>
+            <a:r>
+              <a:rPr lang="en-US" sz="800" dirty="0"/>
+              <a:t> = </a:t>
+            </a:r>
+            <a:r>
+              <a:rPr lang="en-US" sz="800" dirty="0" err="1"/>
+              <a:t>NaN</a:t>
+            </a:r>
+            <a:r>
+              <a:rPr lang="en-US" sz="800" dirty="0"/>
+              <a:t>.</a:t>
+            </a:r>
+          </a:p>
+          <a:p>
+            <a:r>
+              <a:rPr lang="en-US" sz="800" dirty="0"/>
+              <a:t>The Risk: Relational SQL inner joins to </a:t>
+            </a:r>
+            <a:r>
+              <a:rPr lang="en-US" sz="800" dirty="0" err="1"/>
+              <a:t>instruments.csv</a:t>
+            </a:r>
+            <a:r>
+              <a:rPr lang="en-US" sz="800" dirty="0"/>
+              <a:t> silently drop 16.5% of all client ledger entries, distorting cash reconciliations.</a:t>
+            </a:r>
+          </a:p>
+          <a:p>
+            <a:r>
+              <a:rPr lang="en-US" sz="800" dirty="0"/>
+              <a:t>Thoughtful Handling:</a:t>
+            </a:r>
+          </a:p>
+          <a:p>
+            <a:r>
+              <a:rPr lang="en-US" sz="800" dirty="0"/>
+              <a:t>Dual-Track Transaction Processing: The data layer separates Securities Trades (requiring instrument metadata) from Cash Flow &amp; Custody Events (keyed on </a:t>
+            </a:r>
+            <a:r>
+              <a:rPr lang="en-US" sz="800" dirty="0" err="1"/>
+              <a:t>portfolio_id</a:t>
+            </a:r>
+            <a:r>
+              <a:rPr lang="en-US" sz="800" dirty="0"/>
+              <a:t> and </a:t>
+            </a:r>
+            <a:r>
+              <a:rPr lang="en-US" sz="800" dirty="0" err="1"/>
+              <a:t>transaction_type</a:t>
+            </a:r>
+            <a:r>
+              <a:rPr lang="en-US" sz="800" dirty="0"/>
+              <a:t>).</a:t>
+            </a:r>
+          </a:p>
+          <a:p>
+            <a:r>
+              <a:rPr lang="en-US" sz="800" dirty="0"/>
+              <a:t>Explicit Fallbacks: Automatically formats descriptions like [Custody/Fee] USD -24,500.00 from narrative fields.</a:t>
+            </a:r>
+          </a:p>
+          <a:p>
+            <a:endParaRPr lang="en-US" sz="800" dirty="0"/>
+          </a:p>
+          <a:p>
+            <a:r>
+              <a:rPr lang="en-US" sz="800" b="1" dirty="0"/>
+              <a:t>4. Cash Holdings Without Cost Basis or Unrealized </a:t>
+            </a:r>
+            <a:r>
+              <a:rPr lang="en-US" sz="800" b="1" dirty="0" err="1"/>
+              <a:t>PnL</a:t>
+            </a:r>
+            <a:endParaRPr lang="en-US" sz="800" b="1" dirty="0"/>
+          </a:p>
+          <a:p>
+            <a:r>
+              <a:rPr lang="en-US" sz="800" dirty="0"/>
+              <a:t>The Imperfection: Pure cash deposits (USD, SGD, CHF, EUR) have </a:t>
+            </a:r>
+            <a:r>
+              <a:rPr lang="en-US" sz="800" dirty="0" err="1"/>
+              <a:t>cost_basis_base</a:t>
+            </a:r>
+            <a:r>
+              <a:rPr lang="en-US" sz="800" dirty="0"/>
+              <a:t> = </a:t>
+            </a:r>
+            <a:r>
+              <a:rPr lang="en-US" sz="800" dirty="0" err="1"/>
+              <a:t>NaN</a:t>
+            </a:r>
+            <a:r>
+              <a:rPr lang="en-US" sz="800" dirty="0"/>
+              <a:t> and </a:t>
+            </a:r>
+            <a:r>
+              <a:rPr lang="en-US" sz="800" dirty="0" err="1"/>
+              <a:t>unrealised_pnl_base</a:t>
+            </a:r>
+            <a:r>
+              <a:rPr lang="en-US" sz="800" dirty="0"/>
+              <a:t> = </a:t>
+            </a:r>
+            <a:r>
+              <a:rPr lang="en-US" sz="800" dirty="0" err="1"/>
+              <a:t>NaN</a:t>
+            </a:r>
+            <a:r>
+              <a:rPr lang="en-US" sz="800" dirty="0"/>
+              <a:t> in </a:t>
+            </a:r>
+            <a:r>
+              <a:rPr lang="en-US" sz="800" dirty="0" err="1"/>
+              <a:t>holdings.csv</a:t>
+            </a:r>
+            <a:r>
+              <a:rPr lang="en-US" sz="800" dirty="0"/>
+              <a:t>.</a:t>
+            </a:r>
+          </a:p>
+          <a:p>
+            <a:r>
+              <a:rPr lang="en-US" sz="800" dirty="0"/>
+              <a:t>The Risk: Tax-loss harvesting engines or </a:t>
+            </a:r>
+            <a:r>
+              <a:rPr lang="en-US" sz="800" dirty="0" err="1"/>
+              <a:t>PnL</a:t>
+            </a:r>
+            <a:r>
+              <a:rPr lang="en-US" sz="800" dirty="0"/>
+              <a:t> aggregators fail on null arithmetic or misidentify cash as an unpriced illiquid asset.</a:t>
+            </a:r>
+          </a:p>
+          <a:p>
+            <a:r>
+              <a:rPr lang="en-US" sz="800" dirty="0"/>
+              <a:t>Thoughtful Handling:</a:t>
+            </a:r>
+          </a:p>
+          <a:p>
+            <a:r>
+              <a:rPr lang="en-US" sz="800" dirty="0"/>
+              <a:t>Asset-Class Specific Calculation: Cash holdings are explicitly isolated (</a:t>
+            </a:r>
+            <a:r>
+              <a:rPr lang="en-US" sz="800" dirty="0" err="1"/>
+              <a:t>asset_class</a:t>
+            </a:r>
+            <a:r>
+              <a:rPr lang="en-US" sz="800" dirty="0"/>
+              <a:t> == 'Cash &amp; Liquidity') and treated with a fixed zero unrealized capital gain (</a:t>
+            </a:r>
+            <a:r>
+              <a:rPr lang="en-US" sz="800" dirty="0" err="1"/>
+              <a:t>PnL</a:t>
+            </a:r>
+            <a:r>
+              <a:rPr lang="en-US" sz="800" dirty="0"/>
+              <a:t> = 0.00, Cost Basis = Market Value).</a:t>
+            </a:r>
+          </a:p>
+          <a:p>
+            <a:r>
+              <a:rPr lang="en-US" sz="800" dirty="0"/>
+              <a:t>Tax Exempt Treatment: Automatically categorized as tax-neutral liquidity in </a:t>
+            </a:r>
+          </a:p>
+          <a:p>
+            <a:endParaRPr lang="en-US" sz="800" dirty="0"/>
+          </a:p>
+          <a:p>
+            <a:r>
+              <a:rPr lang="en-US" sz="800" b="1" dirty="0"/>
+              <a:t>5. Point-in-Time Temporal Leakage (Look-Ahead Bias)</a:t>
+            </a:r>
+          </a:p>
+          <a:p>
+            <a:r>
+              <a:rPr lang="en-US" sz="800" dirty="0"/>
+              <a:t>The Imperfection: Historical databases store future events, notes, and market snapshots on the same table.</a:t>
+            </a:r>
+          </a:p>
+          <a:p>
+            <a:r>
+              <a:rPr lang="en-US" sz="800" dirty="0"/>
+              <a:t>The Risk: If an RM or auditor reviews a March 2026 snapshot, an AI model might cite an event or note written in August 2026 (a serious compliance violation).</a:t>
+            </a:r>
+          </a:p>
+          <a:p>
+            <a:r>
+              <a:rPr lang="en-US" sz="800" dirty="0"/>
+              <a:t>Thoughtful Handling:</a:t>
+            </a:r>
+          </a:p>
+          <a:p>
+            <a:r>
+              <a:rPr lang="en-US" sz="800" dirty="0"/>
+              <a:t>Strict Snapshot Upper-Bounding: All data access functions (</a:t>
+            </a:r>
+            <a:r>
+              <a:rPr lang="en-US" sz="800" dirty="0" err="1"/>
+              <a:t>get_rm_notes</a:t>
+            </a:r>
+            <a:r>
+              <a:rPr lang="en-US" sz="800" dirty="0"/>
+              <a:t>, </a:t>
+            </a:r>
+            <a:r>
+              <a:rPr lang="en-US" sz="800" dirty="0" err="1"/>
+              <a:t>match_events_to_holdings</a:t>
+            </a:r>
+            <a:r>
+              <a:rPr lang="en-US" sz="800" dirty="0"/>
+              <a:t>, </a:t>
+            </a:r>
+            <a:r>
+              <a:rPr lang="en-US" sz="800" dirty="0" err="1"/>
+              <a:t>compute_ltv</a:t>
+            </a:r>
+            <a:r>
+              <a:rPr lang="en-US" sz="800" dirty="0"/>
+              <a:t>) enforce </a:t>
+            </a:r>
+            <a:r>
+              <a:rPr lang="en-US" sz="800" dirty="0" err="1"/>
+              <a:t>event_date</a:t>
+            </a:r>
+            <a:r>
+              <a:rPr lang="en-US" sz="800" dirty="0"/>
+              <a:t> &lt;= </a:t>
+            </a:r>
+            <a:r>
+              <a:rPr lang="en-US" sz="800" dirty="0" err="1"/>
+              <a:t>snapshot_date</a:t>
+            </a:r>
+            <a:r>
+              <a:rPr lang="en-US" sz="800" dirty="0"/>
+              <a:t> and </a:t>
+            </a:r>
+            <a:r>
+              <a:rPr lang="en-US" sz="800" dirty="0" err="1"/>
+              <a:t>note_date</a:t>
+            </a:r>
+            <a:r>
+              <a:rPr lang="en-US" sz="800" dirty="0"/>
+              <a:t> &lt;= </a:t>
+            </a:r>
+            <a:r>
+              <a:rPr lang="en-US" sz="800" dirty="0" err="1"/>
+              <a:t>snapshot_date</a:t>
+            </a:r>
+            <a:r>
+              <a:rPr lang="en-US" sz="800" dirty="0"/>
+              <a:t>.</a:t>
+            </a:r>
+          </a:p>
+          <a:p>
+            <a:r>
+              <a:rPr lang="en-US" sz="800" dirty="0"/>
+              <a:t>Authoritative Event Source: 2026 market developments are strictly bounded by </a:t>
+            </a:r>
+            <a:r>
+              <a:rPr lang="en-US" sz="800" dirty="0" err="1"/>
+              <a:t>event_log.csv</a:t>
+            </a:r>
+            <a:r>
+              <a:rPr lang="en-US" sz="800" dirty="0"/>
+              <a:t> up to the selected point-in-time date.</a:t>
+            </a:r>
+          </a:p>
+          <a:p>
+            <a:endParaRPr lang="en-US" sz="800" dirty="0"/>
+          </a:p>
+          <a:p>
+            <a:r>
+              <a:rPr lang="en-US" sz="800" b="1" dirty="0"/>
+              <a:t>6. Unstructured RM Notes with Negative Constraints &amp; Verbal Refusals</a:t>
+            </a:r>
+          </a:p>
+          <a:p>
+            <a:r>
+              <a:rPr lang="en-US" sz="800" dirty="0"/>
+              <a:t>The Imperfection: RM notes contain free-form natural language with informal overrides ("Client refused tech ideas", "Do not sell Indonesian coal holding", "Daughter's tuition needed in Q3").</a:t>
+            </a:r>
+          </a:p>
+          <a:p>
+            <a:r>
+              <a:rPr lang="en-US" sz="800" dirty="0"/>
+              <a:t>The Risk: Algorithmic rebalancers generate mathematically optimal trades that directly violate explicit verbal client instructions.</a:t>
+            </a:r>
+          </a:p>
+          <a:p>
+            <a:r>
+              <a:rPr lang="en-US" sz="800" dirty="0"/>
+              <a:t>Thoughtful Handling:</a:t>
+            </a:r>
+          </a:p>
+          <a:p>
+            <a:r>
+              <a:rPr lang="en-US" sz="800" dirty="0"/>
+              <a:t>Standing Override Extraction: </a:t>
+            </a:r>
+          </a:p>
+          <a:p>
+            <a:r>
+              <a:rPr lang="en-US" sz="800" dirty="0" err="1"/>
+              <a:t>get_rm_notes</a:t>
+            </a:r>
+            <a:r>
+              <a:rPr lang="en-US" sz="800" dirty="0"/>
+              <a:t>() systematically extracts hard constraints into the deterministic state.</a:t>
+            </a:r>
+          </a:p>
+          <a:p>
+            <a:r>
+              <a:rPr lang="en-US" sz="800" dirty="0"/>
+              <a:t>Negative Guardrails in LLM Prompts: Extracted standing constraints are passed as high-priority constraints to all specialist agents and the </a:t>
+            </a:r>
+            <a:r>
+              <a:rPr lang="en-US" sz="800" dirty="0" err="1"/>
+              <a:t>MasterOrchestrator</a:t>
+            </a:r>
+            <a:r>
+              <a:rPr lang="en-US" sz="800" dirty="0"/>
+              <a:t>.</a:t>
+            </a:r>
+          </a:p>
+        </p:txBody>
+      </p:sp>
+    </p:spTree>
+    <p:extLst>
+      <p:ext uri="{BB962C8B-B14F-4D97-AF65-F5344CB8AC3E}">
+        <p14:creationId xmlns:p14="http://schemas.microsoft.com/office/powerpoint/2010/main" val="1123861756"/>
+      </p:ext>
+    </p:extLst>
   </p:cSld>
   <p:clrMapOvr>
     <a:masterClrMapping/>

</xml_diff>